<commit_message>
Update audit log and presentation deck
</commit_message>
<xml_diff>
--- a/presentation/HR_Scout_Presentation.pptx
+++ b/presentation/HR_Scout_Presentation.pptx
@@ -5,19 +5,19 @@
     <p:sldMasterId id="2147483648" r:id="rId1"/>
   </p:sldMasterIdLst>
   <p:sldIdLst>
-    <p:sldId id="256" r:id="rId7"/>
-    <p:sldId id="257" r:id="rId8"/>
-    <p:sldId id="258" r:id="rId9"/>
-    <p:sldId id="259" r:id="rId10"/>
-    <p:sldId id="260" r:id="rId11"/>
-    <p:sldId id="261" r:id="rId12"/>
-    <p:sldId id="262" r:id="rId13"/>
-    <p:sldId id="263" r:id="rId14"/>
-    <p:sldId id="264" r:id="rId15"/>
-    <p:sldId id="265" r:id="rId16"/>
-    <p:sldId id="266" r:id="rId17"/>
+    <p:sldId id="256" r:id="rId2"/>
+    <p:sldId id="257" r:id="rId3"/>
+    <p:sldId id="258" r:id="rId4"/>
+    <p:sldId id="259" r:id="rId5"/>
+    <p:sldId id="260" r:id="rId6"/>
+    <p:sldId id="261" r:id="rId7"/>
+    <p:sldId id="262" r:id="rId8"/>
+    <p:sldId id="263" r:id="rId9"/>
+    <p:sldId id="264" r:id="rId10"/>
+    <p:sldId id="265" r:id="rId11"/>
+    <p:sldId id="266" r:id="rId12"/>
   </p:sldIdLst>
-  <p:sldSz cx="12188952" cy="6858000" type="screen4x3"/>
+  <p:sldSz cx="12188825" cy="6858000"/>
   <p:notesSz cx="6858000" cy="9144000"/>
   <p:defaultTextStyle>
     <a:defPPr>
@@ -114,6 +114,22 @@
       </a:defRPr>
     </a:lvl9pPr>
   </p:defaultTextStyle>
+  <p:extLst>
+    <p:ext uri="{EFAFB233-063F-42B5-8137-9DF3F51BA10A}">
+      <p15:sldGuideLst xmlns:p15="http://schemas.microsoft.com/office/powerpoint/2012/main">
+        <p15:guide id="1" orient="horz" pos="2160">
+          <p15:clr>
+            <a:srgbClr val="A4A3A4"/>
+          </p15:clr>
+        </p15:guide>
+        <p15:guide id="2" pos="2880">
+          <p15:clr>
+            <a:srgbClr val="A4A3A4"/>
+          </p15:clr>
+        </p15:guide>
+      </p15:sldGuideLst>
+    </p:ext>
+  </p:extLst>
 </p:presentation>
 </file>
 
@@ -155,10 +171,9 @@
           <a:lstStyle/>
           <a:p>
             <a:r>
-              <a:rPr lang="en-US" smtClean="0"/>
+              <a:rPr lang="en-US"/>
               <a:t>Click to edit Master title style</a:t>
             </a:r>
-            <a:endParaRPr lang="en-US"/>
           </a:p>
         </p:txBody>
       </p:sp>
@@ -274,10 +289,9 @@
           </a:lstStyle>
           <a:p>
             <a:r>
-              <a:rPr lang="en-US" smtClean="0"/>
+              <a:rPr lang="en-US"/>
               <a:t>Click to edit Master subtitle style</a:t>
             </a:r>
-            <a:endParaRPr lang="en-US"/>
           </a:p>
         </p:txBody>
       </p:sp>
@@ -298,7 +312,7 @@
           <a:p>
             <a:fld id="{5BCAD085-E8A6-8845-BD4E-CB4CCA059FC4}" type="datetimeFigureOut">
               <a:rPr lang="en-US" smtClean="0"/>
-              <a:t>1/27/13</a:t>
+              <a:t>5/11/2026</a:t>
             </a:fld>
             <a:endParaRPr lang="en-US"/>
           </a:p>
@@ -392,10 +406,9 @@
           <a:lstStyle/>
           <a:p>
             <a:r>
-              <a:rPr lang="en-US" smtClean="0"/>
+              <a:rPr lang="en-US"/>
               <a:t>Click to edit Master title style</a:t>
             </a:r>
-            <a:endParaRPr lang="en-US"/>
           </a:p>
         </p:txBody>
       </p:sp>
@@ -416,38 +429,37 @@
           <a:p>
             <a:pPr lvl="0"/>
             <a:r>
-              <a:rPr lang="en-US" smtClean="0"/>
+              <a:rPr lang="en-US"/>
               <a:t>Click to edit Master text styles</a:t>
             </a:r>
           </a:p>
           <a:p>
             <a:pPr lvl="1"/>
             <a:r>
-              <a:rPr lang="en-US" smtClean="0"/>
+              <a:rPr lang="en-US"/>
               <a:t>Second level</a:t>
             </a:r>
           </a:p>
           <a:p>
             <a:pPr lvl="2"/>
             <a:r>
-              <a:rPr lang="en-US" smtClean="0"/>
+              <a:rPr lang="en-US"/>
               <a:t>Third level</a:t>
             </a:r>
           </a:p>
           <a:p>
             <a:pPr lvl="3"/>
             <a:r>
-              <a:rPr lang="en-US" smtClean="0"/>
+              <a:rPr lang="en-US"/>
               <a:t>Fourth level</a:t>
             </a:r>
           </a:p>
           <a:p>
             <a:pPr lvl="4"/>
             <a:r>
-              <a:rPr lang="en-US" smtClean="0"/>
+              <a:rPr lang="en-US"/>
               <a:t>Fifth level</a:t>
             </a:r>
-            <a:endParaRPr lang="en-US"/>
           </a:p>
         </p:txBody>
       </p:sp>
@@ -468,7 +480,7 @@
           <a:p>
             <a:fld id="{5BCAD085-E8A6-8845-BD4E-CB4CCA059FC4}" type="datetimeFigureOut">
               <a:rPr lang="en-US" smtClean="0"/>
-              <a:t>1/27/13</a:t>
+              <a:t>5/11/2026</a:t>
             </a:fld>
             <a:endParaRPr lang="en-US"/>
           </a:p>
@@ -567,10 +579,9 @@
           <a:lstStyle/>
           <a:p>
             <a:r>
-              <a:rPr lang="en-US" smtClean="0"/>
+              <a:rPr lang="en-US"/>
               <a:t>Click to edit Master title style</a:t>
             </a:r>
-            <a:endParaRPr lang="en-US"/>
           </a:p>
         </p:txBody>
       </p:sp>
@@ -596,38 +607,37 @@
           <a:p>
             <a:pPr lvl="0"/>
             <a:r>
-              <a:rPr lang="en-US" smtClean="0"/>
+              <a:rPr lang="en-US"/>
               <a:t>Click to edit Master text styles</a:t>
             </a:r>
           </a:p>
           <a:p>
             <a:pPr lvl="1"/>
             <a:r>
-              <a:rPr lang="en-US" smtClean="0"/>
+              <a:rPr lang="en-US"/>
               <a:t>Second level</a:t>
             </a:r>
           </a:p>
           <a:p>
             <a:pPr lvl="2"/>
             <a:r>
-              <a:rPr lang="en-US" smtClean="0"/>
+              <a:rPr lang="en-US"/>
               <a:t>Third level</a:t>
             </a:r>
           </a:p>
           <a:p>
             <a:pPr lvl="3"/>
             <a:r>
-              <a:rPr lang="en-US" smtClean="0"/>
+              <a:rPr lang="en-US"/>
               <a:t>Fourth level</a:t>
             </a:r>
           </a:p>
           <a:p>
             <a:pPr lvl="4"/>
             <a:r>
-              <a:rPr lang="en-US" smtClean="0"/>
+              <a:rPr lang="en-US"/>
               <a:t>Fifth level</a:t>
             </a:r>
-            <a:endParaRPr lang="en-US"/>
           </a:p>
         </p:txBody>
       </p:sp>
@@ -648,7 +658,7 @@
           <a:p>
             <a:fld id="{5BCAD085-E8A6-8845-BD4E-CB4CCA059FC4}" type="datetimeFigureOut">
               <a:rPr lang="en-US" smtClean="0"/>
-              <a:t>1/27/13</a:t>
+              <a:t>5/11/2026</a:t>
             </a:fld>
             <a:endParaRPr lang="en-US"/>
           </a:p>
@@ -742,10 +752,9 @@
           <a:lstStyle/>
           <a:p>
             <a:r>
-              <a:rPr lang="en-US" smtClean="0"/>
+              <a:rPr lang="en-US"/>
               <a:t>Click to edit Master title style</a:t>
             </a:r>
-            <a:endParaRPr lang="en-US"/>
           </a:p>
         </p:txBody>
       </p:sp>
@@ -766,38 +775,37 @@
           <a:p>
             <a:pPr lvl="0"/>
             <a:r>
-              <a:rPr lang="en-US" smtClean="0"/>
+              <a:rPr lang="en-US"/>
               <a:t>Click to edit Master text styles</a:t>
             </a:r>
           </a:p>
           <a:p>
             <a:pPr lvl="1"/>
             <a:r>
-              <a:rPr lang="en-US" smtClean="0"/>
+              <a:rPr lang="en-US"/>
               <a:t>Second level</a:t>
             </a:r>
           </a:p>
           <a:p>
             <a:pPr lvl="2"/>
             <a:r>
-              <a:rPr lang="en-US" smtClean="0"/>
+              <a:rPr lang="en-US"/>
               <a:t>Third level</a:t>
             </a:r>
           </a:p>
           <a:p>
             <a:pPr lvl="3"/>
             <a:r>
-              <a:rPr lang="en-US" smtClean="0"/>
+              <a:rPr lang="en-US"/>
               <a:t>Fourth level</a:t>
             </a:r>
           </a:p>
           <a:p>
             <a:pPr lvl="4"/>
             <a:r>
-              <a:rPr lang="en-US" smtClean="0"/>
+              <a:rPr lang="en-US"/>
               <a:t>Fifth level</a:t>
             </a:r>
-            <a:endParaRPr lang="en-US"/>
           </a:p>
         </p:txBody>
       </p:sp>
@@ -818,7 +826,7 @@
           <a:p>
             <a:fld id="{5BCAD085-E8A6-8845-BD4E-CB4CCA059FC4}" type="datetimeFigureOut">
               <a:rPr lang="en-US" smtClean="0"/>
-              <a:t>1/27/13</a:t>
+              <a:t>5/11/2026</a:t>
             </a:fld>
             <a:endParaRPr lang="en-US"/>
           </a:p>
@@ -921,10 +929,9 @@
           </a:lstStyle>
           <a:p>
             <a:r>
-              <a:rPr lang="en-US" smtClean="0"/>
+              <a:rPr lang="en-US"/>
               <a:t>Click to edit Master title style</a:t>
             </a:r>
-            <a:endParaRPr lang="en-US"/>
           </a:p>
         </p:txBody>
       </p:sp>
@@ -1041,7 +1048,7 @@
           <a:p>
             <a:pPr lvl="0"/>
             <a:r>
-              <a:rPr lang="en-US" smtClean="0"/>
+              <a:rPr lang="en-US"/>
               <a:t>Click to edit Master text styles</a:t>
             </a:r>
           </a:p>
@@ -1064,7 +1071,7 @@
           <a:p>
             <a:fld id="{5BCAD085-E8A6-8845-BD4E-CB4CCA059FC4}" type="datetimeFigureOut">
               <a:rPr lang="en-US" smtClean="0"/>
-              <a:t>1/27/13</a:t>
+              <a:t>5/11/2026</a:t>
             </a:fld>
             <a:endParaRPr lang="en-US"/>
           </a:p>
@@ -1158,10 +1165,9 @@
           <a:lstStyle/>
           <a:p>
             <a:r>
-              <a:rPr lang="en-US" smtClean="0"/>
+              <a:rPr lang="en-US"/>
               <a:t>Click to edit Master title style</a:t>
             </a:r>
-            <a:endParaRPr lang="en-US"/>
           </a:p>
         </p:txBody>
       </p:sp>
@@ -1215,38 +1221,37 @@
           <a:p>
             <a:pPr lvl="0"/>
             <a:r>
-              <a:rPr lang="en-US" smtClean="0"/>
+              <a:rPr lang="en-US"/>
               <a:t>Click to edit Master text styles</a:t>
             </a:r>
           </a:p>
           <a:p>
             <a:pPr lvl="1"/>
             <a:r>
-              <a:rPr lang="en-US" smtClean="0"/>
+              <a:rPr lang="en-US"/>
               <a:t>Second level</a:t>
             </a:r>
           </a:p>
           <a:p>
             <a:pPr lvl="2"/>
             <a:r>
-              <a:rPr lang="en-US" smtClean="0"/>
+              <a:rPr lang="en-US"/>
               <a:t>Third level</a:t>
             </a:r>
           </a:p>
           <a:p>
             <a:pPr lvl="3"/>
             <a:r>
-              <a:rPr lang="en-US" smtClean="0"/>
+              <a:rPr lang="en-US"/>
               <a:t>Fourth level</a:t>
             </a:r>
           </a:p>
           <a:p>
             <a:pPr lvl="4"/>
             <a:r>
-              <a:rPr lang="en-US" smtClean="0"/>
+              <a:rPr lang="en-US"/>
               <a:t>Fifth level</a:t>
             </a:r>
-            <a:endParaRPr lang="en-US"/>
           </a:p>
         </p:txBody>
       </p:sp>
@@ -1300,38 +1305,37 @@
           <a:p>
             <a:pPr lvl="0"/>
             <a:r>
-              <a:rPr lang="en-US" smtClean="0"/>
+              <a:rPr lang="en-US"/>
               <a:t>Click to edit Master text styles</a:t>
             </a:r>
           </a:p>
           <a:p>
             <a:pPr lvl="1"/>
             <a:r>
-              <a:rPr lang="en-US" smtClean="0"/>
+              <a:rPr lang="en-US"/>
               <a:t>Second level</a:t>
             </a:r>
           </a:p>
           <a:p>
             <a:pPr lvl="2"/>
             <a:r>
-              <a:rPr lang="en-US" smtClean="0"/>
+              <a:rPr lang="en-US"/>
               <a:t>Third level</a:t>
             </a:r>
           </a:p>
           <a:p>
             <a:pPr lvl="3"/>
             <a:r>
-              <a:rPr lang="en-US" smtClean="0"/>
+              <a:rPr lang="en-US"/>
               <a:t>Fourth level</a:t>
             </a:r>
           </a:p>
           <a:p>
             <a:pPr lvl="4"/>
             <a:r>
-              <a:rPr lang="en-US" smtClean="0"/>
+              <a:rPr lang="en-US"/>
               <a:t>Fifth level</a:t>
             </a:r>
-            <a:endParaRPr lang="en-US"/>
           </a:p>
         </p:txBody>
       </p:sp>
@@ -1352,7 +1356,7 @@
           <a:p>
             <a:fld id="{5BCAD085-E8A6-8845-BD4E-CB4CCA059FC4}" type="datetimeFigureOut">
               <a:rPr lang="en-US" smtClean="0"/>
-              <a:t>1/27/13</a:t>
+              <a:t>5/11/2026</a:t>
             </a:fld>
             <a:endParaRPr lang="en-US"/>
           </a:p>
@@ -1450,10 +1454,9 @@
           </a:lstStyle>
           <a:p>
             <a:r>
-              <a:rPr lang="en-US" smtClean="0"/>
+              <a:rPr lang="en-US"/>
               <a:t>Click to edit Master title style</a:t>
             </a:r>
-            <a:endParaRPr lang="en-US"/>
           </a:p>
         </p:txBody>
       </p:sp>
@@ -1516,7 +1519,7 @@
           <a:p>
             <a:pPr lvl="0"/>
             <a:r>
-              <a:rPr lang="en-US" smtClean="0"/>
+              <a:rPr lang="en-US"/>
               <a:t>Click to edit Master text styles</a:t>
             </a:r>
           </a:p>
@@ -1572,38 +1575,37 @@
           <a:p>
             <a:pPr lvl="0"/>
             <a:r>
-              <a:rPr lang="en-US" smtClean="0"/>
+              <a:rPr lang="en-US"/>
               <a:t>Click to edit Master text styles</a:t>
             </a:r>
           </a:p>
           <a:p>
             <a:pPr lvl="1"/>
             <a:r>
-              <a:rPr lang="en-US" smtClean="0"/>
+              <a:rPr lang="en-US"/>
               <a:t>Second level</a:t>
             </a:r>
           </a:p>
           <a:p>
             <a:pPr lvl="2"/>
             <a:r>
-              <a:rPr lang="en-US" smtClean="0"/>
+              <a:rPr lang="en-US"/>
               <a:t>Third level</a:t>
             </a:r>
           </a:p>
           <a:p>
             <a:pPr lvl="3"/>
             <a:r>
-              <a:rPr lang="en-US" smtClean="0"/>
+              <a:rPr lang="en-US"/>
               <a:t>Fourth level</a:t>
             </a:r>
           </a:p>
           <a:p>
             <a:pPr lvl="4"/>
             <a:r>
-              <a:rPr lang="en-US" smtClean="0"/>
+              <a:rPr lang="en-US"/>
               <a:t>Fifth level</a:t>
             </a:r>
-            <a:endParaRPr lang="en-US"/>
           </a:p>
         </p:txBody>
       </p:sp>
@@ -1666,7 +1668,7 @@
           <a:p>
             <a:pPr lvl="0"/>
             <a:r>
-              <a:rPr lang="en-US" smtClean="0"/>
+              <a:rPr lang="en-US"/>
               <a:t>Click to edit Master text styles</a:t>
             </a:r>
           </a:p>
@@ -1722,38 +1724,37 @@
           <a:p>
             <a:pPr lvl="0"/>
             <a:r>
-              <a:rPr lang="en-US" smtClean="0"/>
+              <a:rPr lang="en-US"/>
               <a:t>Click to edit Master text styles</a:t>
             </a:r>
           </a:p>
           <a:p>
             <a:pPr lvl="1"/>
             <a:r>
-              <a:rPr lang="en-US" smtClean="0"/>
+              <a:rPr lang="en-US"/>
               <a:t>Second level</a:t>
             </a:r>
           </a:p>
           <a:p>
             <a:pPr lvl="2"/>
             <a:r>
-              <a:rPr lang="en-US" smtClean="0"/>
+              <a:rPr lang="en-US"/>
               <a:t>Third level</a:t>
             </a:r>
           </a:p>
           <a:p>
             <a:pPr lvl="3"/>
             <a:r>
-              <a:rPr lang="en-US" smtClean="0"/>
+              <a:rPr lang="en-US"/>
               <a:t>Fourth level</a:t>
             </a:r>
           </a:p>
           <a:p>
             <a:pPr lvl="4"/>
             <a:r>
-              <a:rPr lang="en-US" smtClean="0"/>
+              <a:rPr lang="en-US"/>
               <a:t>Fifth level</a:t>
             </a:r>
-            <a:endParaRPr lang="en-US"/>
           </a:p>
         </p:txBody>
       </p:sp>
@@ -1774,7 +1775,7 @@
           <a:p>
             <a:fld id="{5BCAD085-E8A6-8845-BD4E-CB4CCA059FC4}" type="datetimeFigureOut">
               <a:rPr lang="en-US" smtClean="0"/>
-              <a:t>1/27/13</a:t>
+              <a:t>5/11/2026</a:t>
             </a:fld>
             <a:endParaRPr lang="en-US"/>
           </a:p>
@@ -1868,10 +1869,9 @@
           <a:lstStyle/>
           <a:p>
             <a:r>
-              <a:rPr lang="en-US" smtClean="0"/>
+              <a:rPr lang="en-US"/>
               <a:t>Click to edit Master title style</a:t>
             </a:r>
-            <a:endParaRPr lang="en-US"/>
           </a:p>
         </p:txBody>
       </p:sp>
@@ -1892,7 +1892,7 @@
           <a:p>
             <a:fld id="{5BCAD085-E8A6-8845-BD4E-CB4CCA059FC4}" type="datetimeFigureOut">
               <a:rPr lang="en-US" smtClean="0"/>
-              <a:t>1/27/13</a:t>
+              <a:t>5/11/2026</a:t>
             </a:fld>
             <a:endParaRPr lang="en-US"/>
           </a:p>
@@ -1987,7 +1987,7 @@
           <a:p>
             <a:fld id="{5BCAD085-E8A6-8845-BD4E-CB4CCA059FC4}" type="datetimeFigureOut">
               <a:rPr lang="en-US" smtClean="0"/>
-              <a:t>1/27/13</a:t>
+              <a:t>5/11/2026</a:t>
             </a:fld>
             <a:endParaRPr lang="en-US"/>
           </a:p>
@@ -2090,10 +2090,9 @@
           </a:lstStyle>
           <a:p>
             <a:r>
-              <a:rPr lang="en-US" smtClean="0"/>
+              <a:rPr lang="en-US"/>
               <a:t>Click to edit Master title style</a:t>
             </a:r>
-            <a:endParaRPr lang="en-US"/>
           </a:p>
         </p:txBody>
       </p:sp>
@@ -2147,38 +2146,37 @@
           <a:p>
             <a:pPr lvl="0"/>
             <a:r>
-              <a:rPr lang="en-US" smtClean="0"/>
+              <a:rPr lang="en-US"/>
               <a:t>Click to edit Master text styles</a:t>
             </a:r>
           </a:p>
           <a:p>
             <a:pPr lvl="1"/>
             <a:r>
-              <a:rPr lang="en-US" smtClean="0"/>
+              <a:rPr lang="en-US"/>
               <a:t>Second level</a:t>
             </a:r>
           </a:p>
           <a:p>
             <a:pPr lvl="2"/>
             <a:r>
-              <a:rPr lang="en-US" smtClean="0"/>
+              <a:rPr lang="en-US"/>
               <a:t>Third level</a:t>
             </a:r>
           </a:p>
           <a:p>
             <a:pPr lvl="3"/>
             <a:r>
-              <a:rPr lang="en-US" smtClean="0"/>
+              <a:rPr lang="en-US"/>
               <a:t>Fourth level</a:t>
             </a:r>
           </a:p>
           <a:p>
             <a:pPr lvl="4"/>
             <a:r>
-              <a:rPr lang="en-US" smtClean="0"/>
+              <a:rPr lang="en-US"/>
               <a:t>Fifth level</a:t>
             </a:r>
-            <a:endParaRPr lang="en-US"/>
           </a:p>
         </p:txBody>
       </p:sp>
@@ -2241,7 +2239,7 @@
           <a:p>
             <a:pPr lvl="0"/>
             <a:r>
-              <a:rPr lang="en-US" smtClean="0"/>
+              <a:rPr lang="en-US"/>
               <a:t>Click to edit Master text styles</a:t>
             </a:r>
           </a:p>
@@ -2264,7 +2262,7 @@
           <a:p>
             <a:fld id="{5BCAD085-E8A6-8845-BD4E-CB4CCA059FC4}" type="datetimeFigureOut">
               <a:rPr lang="en-US" smtClean="0"/>
-              <a:t>1/27/13</a:t>
+              <a:t>5/11/2026</a:t>
             </a:fld>
             <a:endParaRPr lang="en-US"/>
           </a:p>
@@ -2367,10 +2365,9 @@
           </a:lstStyle>
           <a:p>
             <a:r>
-              <a:rPr lang="en-US" smtClean="0"/>
+              <a:rPr lang="en-US"/>
               <a:t>Click to edit Master title style</a:t>
             </a:r>
-            <a:endParaRPr lang="en-US"/>
           </a:p>
         </p:txBody>
       </p:sp>
@@ -2494,7 +2491,7 @@
           <a:p>
             <a:pPr lvl="0"/>
             <a:r>
-              <a:rPr lang="en-US" smtClean="0"/>
+              <a:rPr lang="en-US"/>
               <a:t>Click to edit Master text styles</a:t>
             </a:r>
           </a:p>
@@ -2517,7 +2514,7 @@
           <a:p>
             <a:fld id="{5BCAD085-E8A6-8845-BD4E-CB4CCA059FC4}" type="datetimeFigureOut">
               <a:rPr lang="en-US" smtClean="0"/>
-              <a:t>1/27/13</a:t>
+              <a:t>5/11/2026</a:t>
             </a:fld>
             <a:endParaRPr lang="en-US"/>
           </a:p>
@@ -2626,10 +2623,9 @@
           <a:lstStyle/>
           <a:p>
             <a:r>
-              <a:rPr lang="en-US" smtClean="0"/>
+              <a:rPr lang="en-US"/>
               <a:t>Click to edit Master title style</a:t>
             </a:r>
-            <a:endParaRPr lang="en-US"/>
           </a:p>
         </p:txBody>
       </p:sp>
@@ -2660,38 +2656,37 @@
           <a:p>
             <a:pPr lvl="0"/>
             <a:r>
-              <a:rPr lang="en-US" smtClean="0"/>
+              <a:rPr lang="en-US"/>
               <a:t>Click to edit Master text styles</a:t>
             </a:r>
           </a:p>
           <a:p>
             <a:pPr lvl="1"/>
             <a:r>
-              <a:rPr lang="en-US" smtClean="0"/>
+              <a:rPr lang="en-US"/>
               <a:t>Second level</a:t>
             </a:r>
           </a:p>
           <a:p>
             <a:pPr lvl="2"/>
             <a:r>
-              <a:rPr lang="en-US" smtClean="0"/>
+              <a:rPr lang="en-US"/>
               <a:t>Third level</a:t>
             </a:r>
           </a:p>
           <a:p>
             <a:pPr lvl="3"/>
             <a:r>
-              <a:rPr lang="en-US" smtClean="0"/>
+              <a:rPr lang="en-US"/>
               <a:t>Fourth level</a:t>
             </a:r>
           </a:p>
           <a:p>
             <a:pPr lvl="4"/>
             <a:r>
-              <a:rPr lang="en-US" smtClean="0"/>
+              <a:rPr lang="en-US"/>
               <a:t>Fifth level</a:t>
             </a:r>
-            <a:endParaRPr lang="en-US"/>
           </a:p>
         </p:txBody>
       </p:sp>
@@ -2730,7 +2725,7 @@
           <a:p>
             <a:fld id="{5BCAD085-E8A6-8845-BD4E-CB4CCA059FC4}" type="datetimeFigureOut">
               <a:rPr lang="en-US" smtClean="0"/>
-              <a:t>1/27/13</a:t>
+              <a:t>5/11/2026</a:t>
             </a:fld>
             <a:endParaRPr lang="en-US"/>
           </a:p>
@@ -3089,7 +3084,7 @@
 </file>
 
 <file path=ppt/slides/slide1.xml><?xml version="1.0" encoding="utf-8"?>
-<p:sld xmlns:a="http://schemas.openxmlformats.org/drawingml/2006/main" xmlns:p="http://schemas.openxmlformats.org/presentationml/2006/main" xmlns:r="http://schemas.openxmlformats.org/officeDocument/2006/relationships">
+<p:sld xmlns:a="http://schemas.openxmlformats.org/drawingml/2006/main" xmlns:r="http://schemas.openxmlformats.org/officeDocument/2006/relationships" xmlns:p="http://schemas.openxmlformats.org/presentationml/2006/main">
   <p:cSld>
     <p:bg>
       <p:bgPr>
@@ -3105,7 +3100,14 @@
         <p:cNvGrpSpPr/>
         <p:nvPr/>
       </p:nvGrpSpPr>
-      <p:grpSpPr/>
+      <p:grpSpPr>
+        <a:xfrm>
+          <a:off x="0" y="0"/>
+          <a:ext cx="0" cy="0"/>
+          <a:chOff x="0" y="0"/>
+          <a:chExt cx="0" cy="0"/>
+        </a:xfrm>
+      </p:grpSpPr>
       <p:sp>
         <p:nvSpPr>
           <p:cNvPr id="2" name="Rectangle 1"/>
@@ -3146,6 +3148,7 @@
           <a:lstStyle/>
           <a:p>
             <a:pPr algn="ctr"/>
+            <a:endParaRPr/>
           </a:p>
         </p:txBody>
       </p:sp>
@@ -3333,7 +3336,7 @@
 </file>
 
 <file path=ppt/slides/slide10.xml><?xml version="1.0" encoding="utf-8"?>
-<p:sld xmlns:a="http://schemas.openxmlformats.org/drawingml/2006/main" xmlns:p="http://schemas.openxmlformats.org/presentationml/2006/main" xmlns:r="http://schemas.openxmlformats.org/officeDocument/2006/relationships">
+<p:sld xmlns:a="http://schemas.openxmlformats.org/drawingml/2006/main" xmlns:r="http://schemas.openxmlformats.org/officeDocument/2006/relationships" xmlns:p="http://schemas.openxmlformats.org/presentationml/2006/main">
   <p:cSld>
     <p:bg>
       <p:bgPr>
@@ -3349,7 +3352,14 @@
         <p:cNvGrpSpPr/>
         <p:nvPr/>
       </p:nvGrpSpPr>
-      <p:grpSpPr/>
+      <p:grpSpPr>
+        <a:xfrm>
+          <a:off x="0" y="0"/>
+          <a:ext cx="0" cy="0"/>
+          <a:chOff x="0" y="0"/>
+          <a:chExt cx="0" cy="0"/>
+        </a:xfrm>
+      </p:grpSpPr>
       <p:sp>
         <p:nvSpPr>
           <p:cNvPr id="2" name="Rectangle 1"/>
@@ -3390,6 +3400,7 @@
           <a:lstStyle/>
           <a:p>
             <a:pPr algn="ctr"/>
+            <a:endParaRPr/>
           </a:p>
         </p:txBody>
       </p:sp>
@@ -3503,6 +3514,7 @@
           <a:lstStyle/>
           <a:p>
             <a:pPr algn="ctr"/>
+            <a:endParaRPr/>
           </a:p>
         </p:txBody>
       </p:sp>
@@ -3548,6 +3560,7 @@
           <a:lstStyle/>
           <a:p>
             <a:pPr algn="ctr"/>
+            <a:endParaRPr/>
           </a:p>
         </p:txBody>
       </p:sp>
@@ -3663,6 +3676,7 @@
           <a:lstStyle/>
           <a:p>
             <a:pPr algn="ctr"/>
+            <a:endParaRPr/>
           </a:p>
         </p:txBody>
       </p:sp>
@@ -3778,6 +3792,7 @@
           <a:lstStyle/>
           <a:p>
             <a:pPr algn="ctr"/>
+            <a:endParaRPr/>
           </a:p>
         </p:txBody>
       </p:sp>
@@ -3893,6 +3908,7 @@
           <a:lstStyle/>
           <a:p>
             <a:pPr algn="ctr"/>
+            <a:endParaRPr/>
           </a:p>
         </p:txBody>
       </p:sp>
@@ -4008,6 +4024,7 @@
           <a:lstStyle/>
           <a:p>
             <a:pPr algn="ctr"/>
+            <a:endParaRPr/>
           </a:p>
         </p:txBody>
       </p:sp>
@@ -4123,6 +4140,7 @@
           <a:lstStyle/>
           <a:p>
             <a:pPr algn="ctr"/>
+            <a:endParaRPr/>
           </a:p>
         </p:txBody>
       </p:sp>
@@ -4205,7 +4223,7 @@
 </file>
 
 <file path=ppt/slides/slide11.xml><?xml version="1.0" encoding="utf-8"?>
-<p:sld xmlns:a="http://schemas.openxmlformats.org/drawingml/2006/main" xmlns:p="http://schemas.openxmlformats.org/presentationml/2006/main" xmlns:r="http://schemas.openxmlformats.org/officeDocument/2006/relationships">
+<p:sld xmlns:a="http://schemas.openxmlformats.org/drawingml/2006/main" xmlns:r="http://schemas.openxmlformats.org/officeDocument/2006/relationships" xmlns:p="http://schemas.openxmlformats.org/presentationml/2006/main">
   <p:cSld>
     <p:bg>
       <p:bgPr>
@@ -4221,7 +4239,14 @@
         <p:cNvGrpSpPr/>
         <p:nvPr/>
       </p:nvGrpSpPr>
-      <p:grpSpPr/>
+      <p:grpSpPr>
+        <a:xfrm>
+          <a:off x="0" y="0"/>
+          <a:ext cx="0" cy="0"/>
+          <a:chOff x="0" y="0"/>
+          <a:chExt cx="0" cy="0"/>
+        </a:xfrm>
+      </p:grpSpPr>
       <p:sp>
         <p:nvSpPr>
           <p:cNvPr id="2" name="Rectangle 1"/>
@@ -4262,6 +4287,7 @@
           <a:lstStyle/>
           <a:p>
             <a:pPr algn="ctr"/>
+            <a:endParaRPr/>
           </a:p>
         </p:txBody>
       </p:sp>
@@ -4449,7 +4475,7 @@
 </file>
 
 <file path=ppt/slides/slide2.xml><?xml version="1.0" encoding="utf-8"?>
-<p:sld xmlns:a="http://schemas.openxmlformats.org/drawingml/2006/main" xmlns:p="http://schemas.openxmlformats.org/presentationml/2006/main" xmlns:r="http://schemas.openxmlformats.org/officeDocument/2006/relationships">
+<p:sld xmlns:a="http://schemas.openxmlformats.org/drawingml/2006/main" xmlns:r="http://schemas.openxmlformats.org/officeDocument/2006/relationships" xmlns:p="http://schemas.openxmlformats.org/presentationml/2006/main">
   <p:cSld>
     <p:bg>
       <p:bgPr>
@@ -4465,7 +4491,14 @@
         <p:cNvGrpSpPr/>
         <p:nvPr/>
       </p:nvGrpSpPr>
-      <p:grpSpPr/>
+      <p:grpSpPr>
+        <a:xfrm>
+          <a:off x="0" y="0"/>
+          <a:ext cx="0" cy="0"/>
+          <a:chOff x="0" y="0"/>
+          <a:chExt cx="0" cy="0"/>
+        </a:xfrm>
+      </p:grpSpPr>
       <p:sp>
         <p:nvSpPr>
           <p:cNvPr id="2" name="Rectangle 1"/>
@@ -4506,6 +4539,7 @@
           <a:lstStyle/>
           <a:p>
             <a:pPr algn="ctr"/>
+            <a:endParaRPr/>
           </a:p>
         </p:txBody>
       </p:sp>
@@ -4619,6 +4653,7 @@
           <a:lstStyle/>
           <a:p>
             <a:pPr algn="ctr"/>
+            <a:endParaRPr/>
           </a:p>
         </p:txBody>
       </p:sp>
@@ -4664,6 +4699,7 @@
           <a:lstStyle/>
           <a:p>
             <a:pPr algn="ctr"/>
+            <a:endParaRPr/>
           </a:p>
         </p:txBody>
       </p:sp>
@@ -4779,6 +4815,7 @@
           <a:lstStyle/>
           <a:p>
             <a:pPr algn="ctr"/>
+            <a:endParaRPr/>
           </a:p>
         </p:txBody>
       </p:sp>
@@ -4894,6 +4931,7 @@
           <a:lstStyle/>
           <a:p>
             <a:pPr algn="ctr"/>
+            <a:endParaRPr/>
           </a:p>
         </p:txBody>
       </p:sp>
@@ -5009,6 +5047,7 @@
           <a:lstStyle/>
           <a:p>
             <a:pPr algn="ctr"/>
+            <a:endParaRPr/>
           </a:p>
         </p:txBody>
       </p:sp>
@@ -5124,6 +5163,7 @@
           <a:lstStyle/>
           <a:p>
             <a:pPr algn="ctr"/>
+            <a:endParaRPr/>
           </a:p>
         </p:txBody>
       </p:sp>
@@ -5206,7 +5246,7 @@
 </file>
 
 <file path=ppt/slides/slide3.xml><?xml version="1.0" encoding="utf-8"?>
-<p:sld xmlns:a="http://schemas.openxmlformats.org/drawingml/2006/main" xmlns:p="http://schemas.openxmlformats.org/presentationml/2006/main" xmlns:r="http://schemas.openxmlformats.org/officeDocument/2006/relationships">
+<p:sld xmlns:a="http://schemas.openxmlformats.org/drawingml/2006/main" xmlns:r="http://schemas.openxmlformats.org/officeDocument/2006/relationships" xmlns:p="http://schemas.openxmlformats.org/presentationml/2006/main">
   <p:cSld>
     <p:bg>
       <p:bgPr>
@@ -5222,7 +5262,14 @@
         <p:cNvGrpSpPr/>
         <p:nvPr/>
       </p:nvGrpSpPr>
-      <p:grpSpPr/>
+      <p:grpSpPr>
+        <a:xfrm>
+          <a:off x="0" y="0"/>
+          <a:ext cx="0" cy="0"/>
+          <a:chOff x="0" y="0"/>
+          <a:chExt cx="0" cy="0"/>
+        </a:xfrm>
+      </p:grpSpPr>
       <p:sp>
         <p:nvSpPr>
           <p:cNvPr id="2" name="Rectangle 1"/>
@@ -5263,6 +5310,7 @@
           <a:lstStyle/>
           <a:p>
             <a:pPr algn="ctr"/>
+            <a:endParaRPr/>
           </a:p>
         </p:txBody>
       </p:sp>
@@ -5376,6 +5424,7 @@
           <a:lstStyle/>
           <a:p>
             <a:pPr algn="ctr"/>
+            <a:endParaRPr/>
           </a:p>
         </p:txBody>
       </p:sp>
@@ -5421,6 +5470,7 @@
           <a:lstStyle/>
           <a:p>
             <a:pPr algn="ctr"/>
+            <a:endParaRPr/>
           </a:p>
         </p:txBody>
       </p:sp>
@@ -5536,6 +5586,7 @@
           <a:lstStyle/>
           <a:p>
             <a:pPr algn="ctr"/>
+            <a:endParaRPr/>
           </a:p>
         </p:txBody>
       </p:sp>
@@ -5651,6 +5702,7 @@
           <a:lstStyle/>
           <a:p>
             <a:pPr algn="ctr"/>
+            <a:endParaRPr/>
           </a:p>
         </p:txBody>
       </p:sp>
@@ -5766,6 +5818,7 @@
           <a:lstStyle/>
           <a:p>
             <a:pPr algn="ctr"/>
+            <a:endParaRPr/>
           </a:p>
         </p:txBody>
       </p:sp>
@@ -5881,6 +5934,7 @@
           <a:lstStyle/>
           <a:p>
             <a:pPr algn="ctr"/>
+            <a:endParaRPr/>
           </a:p>
         </p:txBody>
       </p:sp>
@@ -5963,7 +6017,7 @@
 </file>
 
 <file path=ppt/slides/slide4.xml><?xml version="1.0" encoding="utf-8"?>
-<p:sld xmlns:a="http://schemas.openxmlformats.org/drawingml/2006/main" xmlns:p="http://schemas.openxmlformats.org/presentationml/2006/main" xmlns:r="http://schemas.openxmlformats.org/officeDocument/2006/relationships">
+<p:sld xmlns:a="http://schemas.openxmlformats.org/drawingml/2006/main" xmlns:r="http://schemas.openxmlformats.org/officeDocument/2006/relationships" xmlns:p="http://schemas.openxmlformats.org/presentationml/2006/main">
   <p:cSld>
     <p:bg>
       <p:bgPr>
@@ -5979,7 +6033,14 @@
         <p:cNvGrpSpPr/>
         <p:nvPr/>
       </p:nvGrpSpPr>
-      <p:grpSpPr/>
+      <p:grpSpPr>
+        <a:xfrm>
+          <a:off x="0" y="0"/>
+          <a:ext cx="0" cy="0"/>
+          <a:chOff x="0" y="0"/>
+          <a:chExt cx="0" cy="0"/>
+        </a:xfrm>
+      </p:grpSpPr>
       <p:sp>
         <p:nvSpPr>
           <p:cNvPr id="2" name="Rectangle 1"/>
@@ -6020,6 +6081,7 @@
           <a:lstStyle/>
           <a:p>
             <a:pPr algn="ctr"/>
+            <a:endParaRPr/>
           </a:p>
         </p:txBody>
       </p:sp>
@@ -6133,6 +6195,7 @@
           <a:lstStyle/>
           <a:p>
             <a:pPr algn="ctr"/>
+            <a:endParaRPr/>
           </a:p>
         </p:txBody>
       </p:sp>
@@ -6176,6 +6239,7 @@
           <a:lstStyle/>
           <a:p>
             <a:pPr algn="ctr"/>
+            <a:endParaRPr/>
           </a:p>
         </p:txBody>
       </p:sp>
@@ -6326,6 +6390,7 @@
           <a:lstStyle/>
           <a:p>
             <a:pPr algn="ctr"/>
+            <a:endParaRPr/>
           </a:p>
         </p:txBody>
       </p:sp>
@@ -6476,6 +6541,7 @@
           <a:lstStyle/>
           <a:p>
             <a:pPr algn="ctr"/>
+            <a:endParaRPr/>
           </a:p>
         </p:txBody>
       </p:sp>
@@ -6626,6 +6692,7 @@
           <a:lstStyle/>
           <a:p>
             <a:pPr algn="ctr"/>
+            <a:endParaRPr/>
           </a:p>
         </p:txBody>
       </p:sp>
@@ -6745,7 +6812,7 @@
 </file>
 
 <file path=ppt/slides/slide5.xml><?xml version="1.0" encoding="utf-8"?>
-<p:sld xmlns:a="http://schemas.openxmlformats.org/drawingml/2006/main" xmlns:p="http://schemas.openxmlformats.org/presentationml/2006/main" xmlns:r="http://schemas.openxmlformats.org/officeDocument/2006/relationships">
+<p:sld xmlns:a="http://schemas.openxmlformats.org/drawingml/2006/main" xmlns:r="http://schemas.openxmlformats.org/officeDocument/2006/relationships" xmlns:p="http://schemas.openxmlformats.org/presentationml/2006/main">
   <p:cSld>
     <p:bg>
       <p:bgPr>
@@ -6761,7 +6828,14 @@
         <p:cNvGrpSpPr/>
         <p:nvPr/>
       </p:nvGrpSpPr>
-      <p:grpSpPr/>
+      <p:grpSpPr>
+        <a:xfrm>
+          <a:off x="0" y="0"/>
+          <a:ext cx="0" cy="0"/>
+          <a:chOff x="0" y="0"/>
+          <a:chExt cx="0" cy="0"/>
+        </a:xfrm>
+      </p:grpSpPr>
       <p:sp>
         <p:nvSpPr>
           <p:cNvPr id="2" name="Rectangle 1"/>
@@ -6802,6 +6876,7 @@
           <a:lstStyle/>
           <a:p>
             <a:pPr algn="ctr"/>
+            <a:endParaRPr/>
           </a:p>
         </p:txBody>
       </p:sp>
@@ -6915,6 +6990,7 @@
           <a:lstStyle/>
           <a:p>
             <a:pPr algn="ctr"/>
+            <a:endParaRPr/>
           </a:p>
         </p:txBody>
       </p:sp>
@@ -6960,6 +7036,7 @@
           <a:lstStyle/>
           <a:p>
             <a:pPr algn="ctr"/>
+            <a:endParaRPr/>
           </a:p>
         </p:txBody>
       </p:sp>
@@ -7003,6 +7080,7 @@
           <a:lstStyle/>
           <a:p>
             <a:pPr algn="ctr"/>
+            <a:endParaRPr/>
           </a:p>
         </p:txBody>
       </p:sp>
@@ -7154,6 +7232,7 @@
           <a:lstStyle/>
           <a:p>
             <a:pPr algn="ctr"/>
+            <a:endParaRPr/>
           </a:p>
         </p:txBody>
       </p:sp>
@@ -7197,6 +7276,7 @@
           <a:lstStyle/>
           <a:p>
             <a:pPr algn="ctr"/>
+            <a:endParaRPr/>
           </a:p>
         </p:txBody>
       </p:sp>
@@ -7348,6 +7428,7 @@
           <a:lstStyle/>
           <a:p>
             <a:pPr algn="ctr"/>
+            <a:endParaRPr/>
           </a:p>
         </p:txBody>
       </p:sp>
@@ -7391,6 +7472,7 @@
           <a:lstStyle/>
           <a:p>
             <a:pPr algn="ctr"/>
+            <a:endParaRPr/>
           </a:p>
         </p:txBody>
       </p:sp>
@@ -7542,6 +7624,7 @@
           <a:lstStyle/>
           <a:p>
             <a:pPr algn="ctr"/>
+            <a:endParaRPr/>
           </a:p>
         </p:txBody>
       </p:sp>
@@ -7585,6 +7668,7 @@
           <a:lstStyle/>
           <a:p>
             <a:pPr algn="ctr"/>
+            <a:endParaRPr/>
           </a:p>
         </p:txBody>
       </p:sp>
@@ -7736,6 +7820,7 @@
           <a:lstStyle/>
           <a:p>
             <a:pPr algn="ctr"/>
+            <a:endParaRPr/>
           </a:p>
         </p:txBody>
       </p:sp>
@@ -7779,6 +7864,7 @@
           <a:lstStyle/>
           <a:p>
             <a:pPr algn="ctr"/>
+            <a:endParaRPr/>
           </a:p>
         </p:txBody>
       </p:sp>
@@ -7930,6 +8016,7 @@
           <a:lstStyle/>
           <a:p>
             <a:pPr algn="ctr"/>
+            <a:endParaRPr/>
           </a:p>
         </p:txBody>
       </p:sp>
@@ -7973,6 +8060,7 @@
           <a:lstStyle/>
           <a:p>
             <a:pPr algn="ctr"/>
+            <a:endParaRPr/>
           </a:p>
         </p:txBody>
       </p:sp>
@@ -8126,7 +8214,7 @@
 </file>
 
 <file path=ppt/slides/slide6.xml><?xml version="1.0" encoding="utf-8"?>
-<p:sld xmlns:a="http://schemas.openxmlformats.org/drawingml/2006/main" xmlns:p="http://schemas.openxmlformats.org/presentationml/2006/main" xmlns:r="http://schemas.openxmlformats.org/officeDocument/2006/relationships">
+<p:sld xmlns:a="http://schemas.openxmlformats.org/drawingml/2006/main" xmlns:r="http://schemas.openxmlformats.org/officeDocument/2006/relationships" xmlns:p="http://schemas.openxmlformats.org/presentationml/2006/main">
   <p:cSld>
     <p:bg>
       <p:bgPr>
@@ -8142,7 +8230,14 @@
         <p:cNvGrpSpPr/>
         <p:nvPr/>
       </p:nvGrpSpPr>
-      <p:grpSpPr/>
+      <p:grpSpPr>
+        <a:xfrm>
+          <a:off x="0" y="0"/>
+          <a:ext cx="0" cy="0"/>
+          <a:chOff x="0" y="0"/>
+          <a:chExt cx="0" cy="0"/>
+        </a:xfrm>
+      </p:grpSpPr>
       <p:sp>
         <p:nvSpPr>
           <p:cNvPr id="2" name="Rectangle 1"/>
@@ -8183,6 +8278,7 @@
           <a:lstStyle/>
           <a:p>
             <a:pPr algn="ctr"/>
+            <a:endParaRPr/>
           </a:p>
         </p:txBody>
       </p:sp>
@@ -8296,6 +8392,7 @@
           <a:lstStyle/>
           <a:p>
             <a:pPr algn="ctr"/>
+            <a:endParaRPr/>
           </a:p>
         </p:txBody>
       </p:sp>
@@ -8339,6 +8436,7 @@
           <a:lstStyle/>
           <a:p>
             <a:pPr algn="ctr"/>
+            <a:endParaRPr/>
           </a:p>
         </p:txBody>
       </p:sp>
@@ -8522,6 +8620,7 @@
           <a:lstStyle/>
           <a:p>
             <a:pPr algn="ctr"/>
+            <a:endParaRPr/>
           </a:p>
         </p:txBody>
       </p:sp>
@@ -8635,6 +8734,7 @@
           <a:lstStyle/>
           <a:p>
             <a:pPr algn="ctr"/>
+            <a:endParaRPr/>
           </a:p>
         </p:txBody>
       </p:sp>
@@ -8678,6 +8778,7 @@
           <a:lstStyle/>
           <a:p>
             <a:pPr algn="ctr"/>
+            <a:endParaRPr/>
           </a:p>
         </p:txBody>
       </p:sp>
@@ -8756,6 +8857,7 @@
           <a:lstStyle/>
           <a:p>
             <a:pPr algn="ctr"/>
+            <a:endParaRPr/>
           </a:p>
         </p:txBody>
       </p:sp>
@@ -8869,6 +8971,7 @@
           <a:lstStyle/>
           <a:p>
             <a:pPr algn="ctr"/>
+            <a:endParaRPr/>
           </a:p>
         </p:txBody>
       </p:sp>
@@ -8912,6 +9015,7 @@
           <a:lstStyle/>
           <a:p>
             <a:pPr algn="ctr"/>
+            <a:endParaRPr/>
           </a:p>
         </p:txBody>
       </p:sp>
@@ -8990,6 +9094,7 @@
           <a:lstStyle/>
           <a:p>
             <a:pPr algn="ctr"/>
+            <a:endParaRPr/>
           </a:p>
         </p:txBody>
       </p:sp>
@@ -9103,6 +9208,7 @@
           <a:lstStyle/>
           <a:p>
             <a:pPr algn="ctr"/>
+            <a:endParaRPr/>
           </a:p>
         </p:txBody>
       </p:sp>
@@ -9146,6 +9252,7 @@
           <a:lstStyle/>
           <a:p>
             <a:pPr algn="ctr"/>
+            <a:endParaRPr/>
           </a:p>
         </p:txBody>
       </p:sp>
@@ -9224,6 +9331,7 @@
           <a:lstStyle/>
           <a:p>
             <a:pPr algn="ctr"/>
+            <a:endParaRPr/>
           </a:p>
         </p:txBody>
       </p:sp>
@@ -9337,6 +9445,7 @@
           <a:lstStyle/>
           <a:p>
             <a:pPr algn="ctr"/>
+            <a:endParaRPr/>
           </a:p>
         </p:txBody>
       </p:sp>
@@ -9380,6 +9489,7 @@
           <a:lstStyle/>
           <a:p>
             <a:pPr algn="ctr"/>
+            <a:endParaRPr/>
           </a:p>
         </p:txBody>
       </p:sp>
@@ -9458,6 +9568,7 @@
           <a:lstStyle/>
           <a:p>
             <a:pPr algn="ctr"/>
+            <a:endParaRPr/>
           </a:p>
         </p:txBody>
       </p:sp>
@@ -9571,6 +9682,7 @@
           <a:lstStyle/>
           <a:p>
             <a:pPr algn="ctr"/>
+            <a:endParaRPr/>
           </a:p>
         </p:txBody>
       </p:sp>
@@ -9614,6 +9726,7 @@
           <a:lstStyle/>
           <a:p>
             <a:pPr algn="ctr"/>
+            <a:endParaRPr/>
           </a:p>
         </p:txBody>
       </p:sp>
@@ -9696,7 +9809,7 @@
 </file>
 
 <file path=ppt/slides/slide7.xml><?xml version="1.0" encoding="utf-8"?>
-<p:sld xmlns:a="http://schemas.openxmlformats.org/drawingml/2006/main" xmlns:p="http://schemas.openxmlformats.org/presentationml/2006/main" xmlns:r="http://schemas.openxmlformats.org/officeDocument/2006/relationships">
+<p:sld xmlns:a="http://schemas.openxmlformats.org/drawingml/2006/main" xmlns:r="http://schemas.openxmlformats.org/officeDocument/2006/relationships" xmlns:p="http://schemas.openxmlformats.org/presentationml/2006/main">
   <p:cSld>
     <p:bg>
       <p:bgPr>
@@ -9712,7 +9825,14 @@
         <p:cNvGrpSpPr/>
         <p:nvPr/>
       </p:nvGrpSpPr>
-      <p:grpSpPr/>
+      <p:grpSpPr>
+        <a:xfrm>
+          <a:off x="0" y="0"/>
+          <a:ext cx="0" cy="0"/>
+          <a:chOff x="0" y="0"/>
+          <a:chExt cx="0" cy="0"/>
+        </a:xfrm>
+      </p:grpSpPr>
       <p:sp>
         <p:nvSpPr>
           <p:cNvPr id="2" name="Rectangle 1"/>
@@ -9753,6 +9873,7 @@
           <a:lstStyle/>
           <a:p>
             <a:pPr algn="ctr"/>
+            <a:endParaRPr/>
           </a:p>
         </p:txBody>
       </p:sp>
@@ -9866,6 +9987,7 @@
           <a:lstStyle/>
           <a:p>
             <a:pPr algn="ctr"/>
+            <a:endParaRPr/>
           </a:p>
         </p:txBody>
       </p:sp>
@@ -9909,6 +10031,7 @@
           <a:lstStyle/>
           <a:p>
             <a:pPr algn="ctr"/>
+            <a:endParaRPr/>
           </a:p>
         </p:txBody>
       </p:sp>
@@ -9952,6 +10075,7 @@
           <a:lstStyle/>
           <a:p>
             <a:pPr algn="ctr"/>
+            <a:endParaRPr/>
           </a:p>
         </p:txBody>
       </p:sp>
@@ -10100,6 +10224,7 @@
           <a:lstStyle/>
           <a:p>
             <a:pPr algn="ctr"/>
+            <a:endParaRPr/>
           </a:p>
         </p:txBody>
       </p:sp>
@@ -10143,6 +10268,7 @@
           <a:lstStyle/>
           <a:p>
             <a:pPr algn="ctr"/>
+            <a:endParaRPr/>
           </a:p>
         </p:txBody>
       </p:sp>
@@ -10291,6 +10417,7 @@
           <a:lstStyle/>
           <a:p>
             <a:pPr algn="ctr"/>
+            <a:endParaRPr/>
           </a:p>
         </p:txBody>
       </p:sp>
@@ -10334,6 +10461,7 @@
           <a:lstStyle/>
           <a:p>
             <a:pPr algn="ctr"/>
+            <a:endParaRPr/>
           </a:p>
         </p:txBody>
       </p:sp>
@@ -10482,6 +10610,7 @@
           <a:lstStyle/>
           <a:p>
             <a:pPr algn="ctr"/>
+            <a:endParaRPr/>
           </a:p>
         </p:txBody>
       </p:sp>
@@ -10525,6 +10654,7 @@
           <a:lstStyle/>
           <a:p>
             <a:pPr algn="ctr"/>
+            <a:endParaRPr/>
           </a:p>
         </p:txBody>
       </p:sp>
@@ -10673,6 +10803,7 @@
           <a:lstStyle/>
           <a:p>
             <a:pPr algn="ctr"/>
+            <a:endParaRPr/>
           </a:p>
         </p:txBody>
       </p:sp>
@@ -10716,6 +10847,7 @@
           <a:lstStyle/>
           <a:p>
             <a:pPr algn="ctr"/>
+            <a:endParaRPr/>
           </a:p>
         </p:txBody>
       </p:sp>
@@ -10833,7 +10965,7 @@
 </file>
 
 <file path=ppt/slides/slide8.xml><?xml version="1.0" encoding="utf-8"?>
-<p:sld xmlns:a="http://schemas.openxmlformats.org/drawingml/2006/main" xmlns:p="http://schemas.openxmlformats.org/presentationml/2006/main" xmlns:r="http://schemas.openxmlformats.org/officeDocument/2006/relationships">
+<p:sld xmlns:a="http://schemas.openxmlformats.org/drawingml/2006/main" xmlns:r="http://schemas.openxmlformats.org/officeDocument/2006/relationships" xmlns:p="http://schemas.openxmlformats.org/presentationml/2006/main">
   <p:cSld>
     <p:bg>
       <p:bgPr>
@@ -10849,7 +10981,14 @@
         <p:cNvGrpSpPr/>
         <p:nvPr/>
       </p:nvGrpSpPr>
-      <p:grpSpPr/>
+      <p:grpSpPr>
+        <a:xfrm>
+          <a:off x="0" y="0"/>
+          <a:ext cx="0" cy="0"/>
+          <a:chOff x="0" y="0"/>
+          <a:chExt cx="0" cy="0"/>
+        </a:xfrm>
+      </p:grpSpPr>
       <p:sp>
         <p:nvSpPr>
           <p:cNvPr id="2" name="Rectangle 1"/>
@@ -10890,6 +11029,7 @@
           <a:lstStyle/>
           <a:p>
             <a:pPr algn="ctr"/>
+            <a:endParaRPr/>
           </a:p>
         </p:txBody>
       </p:sp>
@@ -11003,6 +11143,7 @@
           <a:lstStyle/>
           <a:p>
             <a:pPr algn="ctr"/>
+            <a:endParaRPr/>
           </a:p>
         </p:txBody>
       </p:sp>
@@ -11022,8 +11163,8 @@
         </p:blipFill>
         <p:spPr>
           <a:xfrm>
-            <a:off x="274320" y="1188720"/>
-            <a:ext cx="5760720" cy="1371600"/>
+            <a:off x="867697" y="1115568"/>
+            <a:ext cx="5167343" cy="2732532"/>
           </a:xfrm>
           <a:prstGeom prst="rect">
             <a:avLst/>
@@ -11065,9 +11206,44 @@
           </a:p>
         </p:txBody>
       </p:sp>
+      <p:sp>
+        <p:nvSpPr>
+          <p:cNvPr id="9" name="TextBox 8"/>
+          <p:cNvSpPr txBox="1"/>
+          <p:nvPr/>
+        </p:nvSpPr>
+        <p:spPr>
+          <a:xfrm>
+            <a:off x="6217920" y="4041648"/>
+            <a:ext cx="5486400" cy="320040"/>
+          </a:xfrm>
+          <a:prstGeom prst="rect">
+            <a:avLst/>
+          </a:prstGeom>
+          <a:noFill/>
+        </p:spPr>
+        <p:txBody>
+          <a:bodyPr wrap="square">
+            <a:spAutoFit/>
+          </a:bodyPr>
+          <a:lstStyle/>
+          <a:p>
+            <a:pPr algn="ctr"/>
+            <a:r>
+              <a:rPr sz="1100" b="0" i="0">
+                <a:solidFill>
+                  <a:srgbClr val="6B7280"/>
+                </a:solidFill>
+                <a:latin typeface="Segoe UI"/>
+              </a:rPr>
+              <a:t>Upload &amp; JD Entry</a:t>
+            </a:r>
+          </a:p>
+        </p:txBody>
+      </p:sp>
       <p:pic>
         <p:nvPicPr>
-          <p:cNvPr id="8" name="Picture 7" descr="02_upload_page.png"/>
+          <p:cNvPr id="10" name="Picture 9" descr="04_ranking_table.png"/>
           <p:cNvPicPr>
             <a:picLocks noChangeAspect="1"/>
           </p:cNvPicPr>
@@ -11081,8 +11257,8 @@
         </p:blipFill>
         <p:spPr>
           <a:xfrm>
-            <a:off x="6217920" y="1188720"/>
-            <a:ext cx="5760720" cy="1371600"/>
+            <a:off x="274320" y="4023359"/>
+            <a:ext cx="5760720" cy="2496657"/>
           </a:xfrm>
           <a:prstGeom prst="rect">
             <a:avLst/>
@@ -11091,13 +11267,13 @@
       </p:pic>
       <p:sp>
         <p:nvSpPr>
-          <p:cNvPr id="9" name="TextBox 8"/>
-          <p:cNvSpPr txBox="1"/>
-          <p:nvPr/>
-        </p:nvSpPr>
-        <p:spPr>
-          <a:xfrm>
-            <a:off x="6217920" y="4041648"/>
+          <p:cNvPr id="11" name="TextBox 10"/>
+          <p:cNvSpPr txBox="1"/>
+          <p:nvPr/>
+        </p:nvSpPr>
+        <p:spPr>
+          <a:xfrm>
+            <a:off x="274320" y="6876288"/>
             <a:ext cx="5486400" cy="320040"/>
           </a:xfrm>
           <a:prstGeom prst="rect">
@@ -11119,14 +11295,14 @@
                 </a:solidFill>
                 <a:latin typeface="Segoe UI"/>
               </a:rPr>
-              <a:t>Upload &amp; JD Entry</a:t>
+              <a:t>Ranking Table</a:t>
             </a:r>
           </a:p>
         </p:txBody>
       </p:sp>
       <p:pic>
         <p:nvPicPr>
-          <p:cNvPr id="10" name="Picture 9" descr="04_ranking_table.png"/>
+          <p:cNvPr id="12" name="Picture 11" descr="07_api_docs.png"/>
           <p:cNvPicPr>
             <a:picLocks noChangeAspect="1"/>
           </p:cNvPicPr>
@@ -11140,8 +11316,8 @@
         </p:blipFill>
         <p:spPr>
           <a:xfrm>
-            <a:off x="274320" y="4023360"/>
-            <a:ext cx="5760720" cy="1371600"/>
+            <a:off x="6217920" y="4041648"/>
+            <a:ext cx="5043835" cy="2651760"/>
           </a:xfrm>
           <a:prstGeom prst="rect">
             <a:avLst/>
@@ -11150,13 +11326,13 @@
       </p:pic>
       <p:sp>
         <p:nvSpPr>
-          <p:cNvPr id="11" name="TextBox 10"/>
-          <p:cNvSpPr txBox="1"/>
-          <p:nvPr/>
-        </p:nvSpPr>
-        <p:spPr>
-          <a:xfrm>
-            <a:off x="274320" y="6876288"/>
+          <p:cNvPr id="13" name="TextBox 12"/>
+          <p:cNvSpPr txBox="1"/>
+          <p:nvPr/>
+        </p:nvSpPr>
+        <p:spPr>
+          <a:xfrm>
+            <a:off x="6217920" y="6876288"/>
             <a:ext cx="5486400" cy="320040"/>
           </a:xfrm>
           <a:prstGeom prst="rect">
@@ -11178,14 +11354,20 @@
                 </a:solidFill>
                 <a:latin typeface="Segoe UI"/>
               </a:rPr>
-              <a:t>Ranking Table</a:t>
+              <a:t>API Documentation</a:t>
             </a:r>
           </a:p>
         </p:txBody>
       </p:sp>
       <p:pic>
         <p:nvPicPr>
-          <p:cNvPr id="12" name="Picture 11" descr="07_api_docs.png"/>
+          <p:cNvPr id="15" name="Picture 14">
+            <a:extLst>
+              <a:ext uri="{FF2B5EF4-FFF2-40B4-BE49-F238E27FC236}">
+                <a16:creationId xmlns:a16="http://schemas.microsoft.com/office/drawing/2014/main" id="{C5AFB4FC-7AB8-378C-79A3-682892175AC6}"/>
+              </a:ext>
+            </a:extLst>
+          </p:cNvPr>
           <p:cNvPicPr>
             <a:picLocks noChangeAspect="1"/>
           </p:cNvPicPr>
@@ -11199,49 +11381,14 @@
         </p:blipFill>
         <p:spPr>
           <a:xfrm>
-            <a:off x="6217920" y="4023360"/>
-            <a:ext cx="5760720" cy="1371600"/>
+            <a:off x="6153786" y="1137197"/>
+            <a:ext cx="4782974" cy="2838625"/>
           </a:xfrm>
           <a:prstGeom prst="rect">
             <a:avLst/>
           </a:prstGeom>
         </p:spPr>
       </p:pic>
-      <p:sp>
-        <p:nvSpPr>
-          <p:cNvPr id="13" name="TextBox 12"/>
-          <p:cNvSpPr txBox="1"/>
-          <p:nvPr/>
-        </p:nvSpPr>
-        <p:spPr>
-          <a:xfrm>
-            <a:off x="6217920" y="6876288"/>
-            <a:ext cx="5486400" cy="320040"/>
-          </a:xfrm>
-          <a:prstGeom prst="rect">
-            <a:avLst/>
-          </a:prstGeom>
-          <a:noFill/>
-        </p:spPr>
-        <p:txBody>
-          <a:bodyPr wrap="square">
-            <a:spAutoFit/>
-          </a:bodyPr>
-          <a:lstStyle/>
-          <a:p>
-            <a:pPr algn="ctr"/>
-            <a:r>
-              <a:rPr sz="1100" b="0" i="0">
-                <a:solidFill>
-                  <a:srgbClr val="6B7280"/>
-                </a:solidFill>
-                <a:latin typeface="Segoe UI"/>
-              </a:rPr>
-              <a:t>API Documentation</a:t>
-            </a:r>
-          </a:p>
-        </p:txBody>
-      </p:sp>
     </p:spTree>
   </p:cSld>
   <p:clrMapOvr>
@@ -11251,7 +11398,7 @@
 </file>
 
 <file path=ppt/slides/slide9.xml><?xml version="1.0" encoding="utf-8"?>
-<p:sld xmlns:a="http://schemas.openxmlformats.org/drawingml/2006/main" xmlns:p="http://schemas.openxmlformats.org/presentationml/2006/main" xmlns:r="http://schemas.openxmlformats.org/officeDocument/2006/relationships">
+<p:sld xmlns:a="http://schemas.openxmlformats.org/drawingml/2006/main" xmlns:r="http://schemas.openxmlformats.org/officeDocument/2006/relationships" xmlns:p="http://schemas.openxmlformats.org/presentationml/2006/main">
   <p:cSld>
     <p:bg>
       <p:bgPr>
@@ -11267,7 +11414,14 @@
         <p:cNvGrpSpPr/>
         <p:nvPr/>
       </p:nvGrpSpPr>
-      <p:grpSpPr/>
+      <p:grpSpPr>
+        <a:xfrm>
+          <a:off x="0" y="0"/>
+          <a:ext cx="0" cy="0"/>
+          <a:chOff x="0" y="0"/>
+          <a:chExt cx="0" cy="0"/>
+        </a:xfrm>
+      </p:grpSpPr>
       <p:sp>
         <p:nvSpPr>
           <p:cNvPr id="2" name="Rectangle 1"/>
@@ -11308,6 +11462,7 @@
           <a:lstStyle/>
           <a:p>
             <a:pPr algn="ctr"/>
+            <a:endParaRPr/>
           </a:p>
         </p:txBody>
       </p:sp>
@@ -11355,7 +11510,7 @@
         <p:spPr>
           <a:xfrm>
             <a:off x="457200" y="640080"/>
-            <a:ext cx="10972800" cy="347472"/>
+            <a:ext cx="10972800" cy="292388"/>
           </a:xfrm>
           <a:prstGeom prst="rect">
             <a:avLst/>
@@ -11370,13 +11525,31 @@
           <a:p>
             <a:pPr algn="l"/>
             <a:r>
-              <a:rPr sz="1300" b="0" i="0">
+              <a:rPr sz="1300" b="0" i="0" dirty="0">
                 <a:solidFill>
                   <a:srgbClr val="6B7280"/>
                 </a:solidFill>
                 <a:latin typeface="Segoe UI"/>
               </a:rPr>
-              <a:t>5 candidates scored against Senior Full-Stack Engineer JD</a:t>
+              <a:t>5 candidates scored against </a:t>
+            </a:r>
+            <a:r>
+              <a:rPr lang="en-IN" sz="1300" dirty="0">
+                <a:solidFill>
+                  <a:srgbClr val="6B7280"/>
+                </a:solidFill>
+                <a:latin typeface="Segoe UI"/>
+              </a:rPr>
+              <a:t>AIML</a:t>
+            </a:r>
+            <a:r>
+              <a:rPr sz="1300" b="0" i="0" dirty="0">
+                <a:solidFill>
+                  <a:srgbClr val="6B7280"/>
+                </a:solidFill>
+                <a:latin typeface="Segoe UI"/>
+              </a:rPr>
+              <a:t> Engineer JD</a:t>
             </a:r>
           </a:p>
         </p:txBody>
@@ -11421,6 +11594,7 @@
           <a:lstStyle/>
           <a:p>
             <a:pPr algn="ctr"/>
+            <a:endParaRPr/>
           </a:p>
         </p:txBody>
       </p:sp>
@@ -11464,6 +11638,7 @@
           <a:lstStyle/>
           <a:p>
             <a:pPr algn="ctr"/>
+            <a:endParaRPr/>
           </a:p>
         </p:txBody>
       </p:sp>
@@ -11647,6 +11822,7 @@
           <a:lstStyle/>
           <a:p>
             <a:pPr algn="ctr"/>
+            <a:endParaRPr/>
           </a:p>
         </p:txBody>
       </p:sp>
@@ -11795,6 +11971,7 @@
           <a:lstStyle/>
           <a:p>
             <a:pPr algn="ctr"/>
+            <a:endParaRPr/>
           </a:p>
         </p:txBody>
       </p:sp>
@@ -11873,6 +12050,7 @@
           <a:lstStyle/>
           <a:p>
             <a:pPr algn="ctr"/>
+            <a:endParaRPr/>
           </a:p>
         </p:txBody>
       </p:sp>
@@ -12021,6 +12199,7 @@
           <a:lstStyle/>
           <a:p>
             <a:pPr algn="ctr"/>
+            <a:endParaRPr/>
           </a:p>
         </p:txBody>
       </p:sp>
@@ -12099,6 +12278,7 @@
           <a:lstStyle/>
           <a:p>
             <a:pPr algn="ctr"/>
+            <a:endParaRPr/>
           </a:p>
         </p:txBody>
       </p:sp>
@@ -12247,6 +12427,7 @@
           <a:lstStyle/>
           <a:p>
             <a:pPr algn="ctr"/>
+            <a:endParaRPr/>
           </a:p>
         </p:txBody>
       </p:sp>
@@ -12325,6 +12506,7 @@
           <a:lstStyle/>
           <a:p>
             <a:pPr algn="ctr"/>
+            <a:endParaRPr/>
           </a:p>
         </p:txBody>
       </p:sp>
@@ -12473,6 +12655,7 @@
           <a:lstStyle/>
           <a:p>
             <a:pPr algn="ctr"/>
+            <a:endParaRPr/>
           </a:p>
         </p:txBody>
       </p:sp>
@@ -12551,6 +12734,7 @@
           <a:lstStyle/>
           <a:p>
             <a:pPr algn="ctr"/>
+            <a:endParaRPr/>
           </a:p>
         </p:txBody>
       </p:sp>
@@ -12699,6 +12883,7 @@
           <a:lstStyle/>
           <a:p>
             <a:pPr algn="ctr"/>
+            <a:endParaRPr/>
           </a:p>
         </p:txBody>
       </p:sp>
@@ -12737,6 +12922,66 @@
           </a:p>
         </p:txBody>
       </p:sp>
+      <p:pic>
+        <p:nvPicPr>
+          <p:cNvPr id="42" name="Picture 41">
+            <a:extLst>
+              <a:ext uri="{FF2B5EF4-FFF2-40B4-BE49-F238E27FC236}">
+                <a16:creationId xmlns:a16="http://schemas.microsoft.com/office/drawing/2014/main" id="{E3523B77-C27D-0106-1A21-8731B08E7762}"/>
+              </a:ext>
+            </a:extLst>
+          </p:cNvPr>
+          <p:cNvPicPr>
+            <a:picLocks noChangeAspect="1"/>
+          </p:cNvPicPr>
+          <p:nvPr/>
+        </p:nvPicPr>
+        <p:blipFill>
+          <a:blip r:embed="rId2"/>
+          <a:stretch>
+            <a:fillRect/>
+          </a:stretch>
+        </p:blipFill>
+        <p:spPr>
+          <a:xfrm>
+            <a:off x="373626" y="1172004"/>
+            <a:ext cx="5882770" cy="4954475"/>
+          </a:xfrm>
+          <a:prstGeom prst="rect">
+            <a:avLst/>
+          </a:prstGeom>
+        </p:spPr>
+      </p:pic>
+      <p:pic>
+        <p:nvPicPr>
+          <p:cNvPr id="44" name="Picture 43">
+            <a:extLst>
+              <a:ext uri="{FF2B5EF4-FFF2-40B4-BE49-F238E27FC236}">
+                <a16:creationId xmlns:a16="http://schemas.microsoft.com/office/drawing/2014/main" id="{D027E2B7-203F-3380-01E6-C95BFFF53398}"/>
+              </a:ext>
+            </a:extLst>
+          </p:cNvPr>
+          <p:cNvPicPr>
+            <a:picLocks noChangeAspect="1"/>
+          </p:cNvPicPr>
+          <p:nvPr/>
+        </p:nvPicPr>
+        <p:blipFill>
+          <a:blip r:embed="rId3"/>
+          <a:stretch>
+            <a:fillRect/>
+          </a:stretch>
+        </p:blipFill>
+        <p:spPr>
+          <a:xfrm>
+            <a:off x="6256396" y="1219003"/>
+            <a:ext cx="5882770" cy="4907477"/>
+          </a:xfrm>
+          <a:prstGeom prst="rect">
+            <a:avLst/>
+          </a:prstGeom>
+        </p:spPr>
+      </p:pic>
     </p:spTree>
   </p:cSld>
   <p:clrMapOvr>

</xml_diff>